<commit_message>
Replace competitor brand name on slide 33 card with generic wording
Co-Authored-By: Claude Opus 5.5 <noreply@anthropic.com>
Claude-Session: https://claude.ai/code/session_01LNckV4PF1WFWnv5VJ442kU
</commit_message>
<xml_diff>
--- a/쿠팡_현황진단1_33장.pptx
+++ b/쿠팡_현황진단1_33장.pptx
@@ -1713,7 +1713,7 @@
                 <a:ea typeface="에이투지체 8 ExtraBold"/>
                 <a:cs typeface="에이투지체 8 ExtraBold"/>
               </a:rPr>
-              <a:t>키움정</a:t>
+              <a:t>경쟁사 광고</a:t>
             </a:r>
           </a:p>
         </p:txBody>
@@ -1824,7 +1824,7 @@
                 <a:ea typeface="에이투지체 4 Regular"/>
                 <a:cs typeface="에이투지체 4 Regular"/>
               </a:rPr>
-              <a:t>아이클타임 검색 첫 줄에 키움정 광고</a:t>
+              <a:t>아이클타임 검색 첫 줄에 경쟁사 광고</a:t>
             </a:r>
           </a:p>
           <a:p>
@@ -1838,7 +1838,7 @@
                 <a:ea typeface="에이투지체 4 Regular"/>
                 <a:cs typeface="에이투지체 4 Regular"/>
               </a:rPr>
-              <a:t>반대로 키움정, 하우투키 검색에는</a:t>
+              <a:t>반대로 경쟁사 브랜드 검색에는</a:t>
             </a:r>
           </a:p>
           <a:p>

</xml_diff>